<commit_message>
Anova for SO4 by depth
</commit_message>
<xml_diff>
--- a/fme_compass_ppt_poster_template_40x48.pptx
+++ b/fme_compass_ppt_poster_template_40x48.pptx
@@ -135,7 +135,7 @@
 <file path=ppt/revisionInfo.xml><?xml version="1.0" encoding="utf-8"?>
 <p1510:revInfo xmlns:a="http://schemas.openxmlformats.org/drawingml/2006/main" xmlns:r="http://schemas.openxmlformats.org/officeDocument/2006/relationships" xmlns:p1510="http://schemas.microsoft.com/office/powerpoint/2015/10/main">
   <p1510:revLst>
-    <p1510:client id="{C361ACA4-D6F5-4BF7-A9F8-CB4C4CECE084}" v="10" dt="2026-03-06T17:29:33.524"/>
+    <p1510:client id="{C361ACA4-D6F5-4BF7-A9F8-CB4C4CECE084}" v="15" dt="2026-03-10T12:42:02.385"/>
   </p1510:revLst>
 </p1510:revInfo>
 </file>
@@ -145,12 +145,12 @@
   <pc:docChgLst>
     <pc:chgData name="Read, Zoe" userId="b08cd0fd-26d2-470b-8ec0-c6e6cb2a79bd" providerId="ADAL" clId="{5AEB2719-95A5-4ED2-9E0E-ED462BB10526}"/>
     <pc:docChg chg="undo custSel modSld">
-      <pc:chgData name="Read, Zoe" userId="b08cd0fd-26d2-470b-8ec0-c6e6cb2a79bd" providerId="ADAL" clId="{5AEB2719-95A5-4ED2-9E0E-ED462BB10526}" dt="2026-03-06T17:29:39.847" v="851" actId="1076"/>
+      <pc:chgData name="Read, Zoe" userId="b08cd0fd-26d2-470b-8ec0-c6e6cb2a79bd" providerId="ADAL" clId="{5AEB2719-95A5-4ED2-9E0E-ED462BB10526}" dt="2026-03-10T12:43:35.979" v="1004" actId="1076"/>
       <pc:docMkLst>
         <pc:docMk/>
       </pc:docMkLst>
       <pc:sldChg chg="addSp delSp modSp mod">
-        <pc:chgData name="Read, Zoe" userId="b08cd0fd-26d2-470b-8ec0-c6e6cb2a79bd" providerId="ADAL" clId="{5AEB2719-95A5-4ED2-9E0E-ED462BB10526}" dt="2026-03-06T17:29:39.847" v="851" actId="1076"/>
+        <pc:chgData name="Read, Zoe" userId="b08cd0fd-26d2-470b-8ec0-c6e6cb2a79bd" providerId="ADAL" clId="{5AEB2719-95A5-4ED2-9E0E-ED462BB10526}" dt="2026-03-10T12:43:35.979" v="1004" actId="1076"/>
         <pc:sldMkLst>
           <pc:docMk/>
           <pc:sldMk cId="2005456116" sldId="257"/>
@@ -172,23 +172,23 @@
           </ac:spMkLst>
         </pc:spChg>
         <pc:spChg chg="mod">
-          <ac:chgData name="Read, Zoe" userId="b08cd0fd-26d2-470b-8ec0-c6e6cb2a79bd" providerId="ADAL" clId="{5AEB2719-95A5-4ED2-9E0E-ED462BB10526}" dt="2026-03-06T17:12:22.592" v="513" actId="14100"/>
+          <ac:chgData name="Read, Zoe" userId="b08cd0fd-26d2-470b-8ec0-c6e6cb2a79bd" providerId="ADAL" clId="{5AEB2719-95A5-4ED2-9E0E-ED462BB10526}" dt="2026-03-09T12:04:44.834" v="864" actId="1076"/>
           <ac:spMkLst>
             <pc:docMk/>
             <pc:sldMk cId="2005456116" sldId="257"/>
             <ac:spMk id="4" creationId="{F1744425-34AA-4364-9092-1BDEEA96FD0B}"/>
           </ac:spMkLst>
         </pc:spChg>
-        <pc:spChg chg="add del mod">
-          <ac:chgData name="Read, Zoe" userId="b08cd0fd-26d2-470b-8ec0-c6e6cb2a79bd" providerId="ADAL" clId="{5AEB2719-95A5-4ED2-9E0E-ED462BB10526}" dt="2026-03-06T17:17:53.777" v="546" actId="478"/>
+        <pc:spChg chg="add mod">
+          <ac:chgData name="Read, Zoe" userId="b08cd0fd-26d2-470b-8ec0-c6e6cb2a79bd" providerId="ADAL" clId="{5AEB2719-95A5-4ED2-9E0E-ED462BB10526}" dt="2026-03-09T12:05:25.785" v="873" actId="1076"/>
           <ac:spMkLst>
             <pc:docMk/>
             <pc:sldMk cId="2005456116" sldId="257"/>
-            <ac:spMk id="6" creationId="{1C8DFDD5-C123-3036-6298-8E839B3A84C8}"/>
+            <ac:spMk id="5" creationId="{611D73CC-38EE-87A4-659B-7AFB71426A3B}"/>
           </ac:spMkLst>
         </pc:spChg>
         <pc:spChg chg="add mod">
-          <ac:chgData name="Read, Zoe" userId="b08cd0fd-26d2-470b-8ec0-c6e6cb2a79bd" providerId="ADAL" clId="{5AEB2719-95A5-4ED2-9E0E-ED462BB10526}" dt="2026-03-06T17:19:07.010" v="668" actId="1076"/>
+          <ac:chgData name="Read, Zoe" userId="b08cd0fd-26d2-470b-8ec0-c6e6cb2a79bd" providerId="ADAL" clId="{5AEB2719-95A5-4ED2-9E0E-ED462BB10526}" dt="2026-03-10T12:43:35.979" v="1004" actId="1076"/>
           <ac:spMkLst>
             <pc:docMk/>
             <pc:sldMk cId="2005456116" sldId="257"/>
@@ -196,71 +196,23 @@
           </ac:spMkLst>
         </pc:spChg>
         <pc:spChg chg="mod">
-          <ac:chgData name="Read, Zoe" userId="b08cd0fd-26d2-470b-8ec0-c6e6cb2a79bd" providerId="ADAL" clId="{5AEB2719-95A5-4ED2-9E0E-ED462BB10526}" dt="2026-03-06T17:25:56.401" v="844" actId="14100"/>
+          <ac:chgData name="Read, Zoe" userId="b08cd0fd-26d2-470b-8ec0-c6e6cb2a79bd" providerId="ADAL" clId="{5AEB2719-95A5-4ED2-9E0E-ED462BB10526}" dt="2026-03-09T12:05:45.091" v="901" actId="20577"/>
           <ac:spMkLst>
             <pc:docMk/>
             <pc:sldMk cId="2005456116" sldId="257"/>
             <ac:spMk id="12" creationId="{0C87B8A1-9733-67EB-E4E3-F2570D73F838}"/>
           </ac:spMkLst>
         </pc:spChg>
-        <pc:spChg chg="del">
-          <ac:chgData name="Read, Zoe" userId="b08cd0fd-26d2-470b-8ec0-c6e6cb2a79bd" providerId="ADAL" clId="{5AEB2719-95A5-4ED2-9E0E-ED462BB10526}" dt="2026-03-06T17:28:46.419" v="847" actId="478"/>
-          <ac:spMkLst>
+        <pc:picChg chg="add del mod">
+          <ac:chgData name="Read, Zoe" userId="b08cd0fd-26d2-470b-8ec0-c6e6cb2a79bd" providerId="ADAL" clId="{5AEB2719-95A5-4ED2-9E0E-ED462BB10526}" dt="2026-03-09T12:17:31.600" v="905" actId="478"/>
+          <ac:picMkLst>
             <pc:docMk/>
             <pc:sldMk cId="2005456116" sldId="257"/>
-            <ac:spMk id="14" creationId="{DAF58BFF-DE4C-C05F-58C3-28535AC2EE29}"/>
-          </ac:spMkLst>
-        </pc:spChg>
-        <pc:spChg chg="mod">
-          <ac:chgData name="Read, Zoe" userId="b08cd0fd-26d2-470b-8ec0-c6e6cb2a79bd" providerId="ADAL" clId="{5AEB2719-95A5-4ED2-9E0E-ED462BB10526}" dt="2026-03-06T17:16:17.257" v="524" actId="1076"/>
-          <ac:spMkLst>
-            <pc:docMk/>
-            <pc:sldMk cId="2005456116" sldId="257"/>
-            <ac:spMk id="18" creationId="{F4161AD5-4983-9A10-9C14-5DAB5EDE247F}"/>
-          </ac:spMkLst>
-        </pc:spChg>
-        <pc:spChg chg="mod">
-          <ac:chgData name="Read, Zoe" userId="b08cd0fd-26d2-470b-8ec0-c6e6cb2a79bd" providerId="ADAL" clId="{5AEB2719-95A5-4ED2-9E0E-ED462BB10526}" dt="2026-03-06T17:16:17.257" v="524" actId="1076"/>
-          <ac:spMkLst>
-            <pc:docMk/>
-            <pc:sldMk cId="2005456116" sldId="257"/>
-            <ac:spMk id="23" creationId="{A41F4E9E-ABDE-0229-3F7F-818F2C2B9CAF}"/>
-          </ac:spMkLst>
-        </pc:spChg>
-        <pc:spChg chg="mod">
-          <ac:chgData name="Read, Zoe" userId="b08cd0fd-26d2-470b-8ec0-c6e6cb2a79bd" providerId="ADAL" clId="{5AEB2719-95A5-4ED2-9E0E-ED462BB10526}" dt="2026-03-06T17:16:17.257" v="524" actId="1076"/>
-          <ac:spMkLst>
-            <pc:docMk/>
-            <pc:sldMk cId="2005456116" sldId="257"/>
-            <ac:spMk id="24" creationId="{B6EA31E6-D1C3-E0E2-EE0F-7F1E2DEFF4B3}"/>
-          </ac:spMkLst>
-        </pc:spChg>
-        <pc:grpChg chg="mod">
-          <ac:chgData name="Read, Zoe" userId="b08cd0fd-26d2-470b-8ec0-c6e6cb2a79bd" providerId="ADAL" clId="{5AEB2719-95A5-4ED2-9E0E-ED462BB10526}" dt="2026-03-06T17:16:17.257" v="524" actId="1076"/>
-          <ac:grpSpMkLst>
-            <pc:docMk/>
-            <pc:sldMk cId="2005456116" sldId="257"/>
-            <ac:grpSpMk id="27" creationId="{4255D2B7-C236-274F-97B6-2BA0A790B363}"/>
-          </ac:grpSpMkLst>
-        </pc:grpChg>
-        <pc:grpChg chg="del mod">
-          <ac:chgData name="Read, Zoe" userId="b08cd0fd-26d2-470b-8ec0-c6e6cb2a79bd" providerId="ADAL" clId="{5AEB2719-95A5-4ED2-9E0E-ED462BB10526}" dt="2026-03-06T17:17:11.740" v="529" actId="478"/>
-          <ac:grpSpMkLst>
-            <pc:docMk/>
-            <pc:sldMk cId="2005456116" sldId="257"/>
-            <ac:grpSpMk id="28" creationId="{2F4868FB-DEDB-FAEA-CEBC-AA8D677AFF6A}"/>
-          </ac:grpSpMkLst>
-        </pc:grpChg>
-        <pc:graphicFrameChg chg="del modGraphic">
-          <ac:chgData name="Read, Zoe" userId="b08cd0fd-26d2-470b-8ec0-c6e6cb2a79bd" providerId="ADAL" clId="{5AEB2719-95A5-4ED2-9E0E-ED462BB10526}" dt="2026-03-06T17:16:56.918" v="527" actId="478"/>
-          <ac:graphicFrameMkLst>
-            <pc:docMk/>
-            <pc:sldMk cId="2005456116" sldId="257"/>
-            <ac:graphicFrameMk id="1032" creationId="{01917035-8FC2-8AC4-CA99-A6FD4F47E001}"/>
-          </ac:graphicFrameMkLst>
-        </pc:graphicFrameChg>
-        <pc:picChg chg="add mod">
-          <ac:chgData name="Read, Zoe" userId="b08cd0fd-26d2-470b-8ec0-c6e6cb2a79bd" providerId="ADAL" clId="{5AEB2719-95A5-4ED2-9E0E-ED462BB10526}" dt="2026-03-06T17:26:02.582" v="846" actId="1076"/>
+            <ac:picMk id="9" creationId="{FF3A475C-502A-AE3E-6697-DF5A24EADBA6}"/>
+          </ac:picMkLst>
+        </pc:picChg>
+        <pc:picChg chg="add del mod">
+          <ac:chgData name="Read, Zoe" userId="b08cd0fd-26d2-470b-8ec0-c6e6cb2a79bd" providerId="ADAL" clId="{5AEB2719-95A5-4ED2-9E0E-ED462BB10526}" dt="2026-03-10T12:41:59.878" v="906" actId="478"/>
           <ac:picMkLst>
             <pc:docMk/>
             <pc:sldMk cId="2005456116" sldId="257"/>
@@ -275,64 +227,24 @@
             <ac:picMk id="13" creationId="{6D65798C-DAB9-914B-7ECA-E6D17BBC9E45}"/>
           </ac:picMkLst>
         </pc:picChg>
-        <pc:picChg chg="del">
-          <ac:chgData name="Read, Zoe" userId="b08cd0fd-26d2-470b-8ec0-c6e6cb2a79bd" providerId="ADAL" clId="{5AEB2719-95A5-4ED2-9E0E-ED462BB10526}" dt="2026-03-06T17:22:15.453" v="753" actId="478"/>
+        <pc:picChg chg="add mod">
+          <ac:chgData name="Read, Zoe" userId="b08cd0fd-26d2-470b-8ec0-c6e6cb2a79bd" providerId="ADAL" clId="{5AEB2719-95A5-4ED2-9E0E-ED462BB10526}" dt="2026-03-10T12:42:29.698" v="917" actId="1076"/>
           <ac:picMkLst>
             <pc:docMk/>
             <pc:sldMk cId="2005456116" sldId="257"/>
-            <ac:picMk id="1025" creationId="{F5578714-414A-9E74-A7A8-02CC39B2448F}"/>
-          </ac:picMkLst>
-        </pc:picChg>
-        <pc:picChg chg="mod">
-          <ac:chgData name="Read, Zoe" userId="b08cd0fd-26d2-470b-8ec0-c6e6cb2a79bd" providerId="ADAL" clId="{5AEB2719-95A5-4ED2-9E0E-ED462BB10526}" dt="2026-03-06T17:16:17.257" v="524" actId="1076"/>
-          <ac:picMkLst>
-            <pc:docMk/>
-            <pc:sldMk cId="2005456116" sldId="257"/>
-            <ac:picMk id="1028" creationId="{C6D98D40-EFBA-EEAF-A463-B121E8492881}"/>
-          </ac:picMkLst>
-        </pc:picChg>
-        <pc:picChg chg="del">
-          <ac:chgData name="Read, Zoe" userId="b08cd0fd-26d2-470b-8ec0-c6e6cb2a79bd" providerId="ADAL" clId="{5AEB2719-95A5-4ED2-9E0E-ED462BB10526}" dt="2026-03-06T17:22:23.700" v="754" actId="478"/>
-          <ac:picMkLst>
-            <pc:docMk/>
-            <pc:sldMk cId="2005456116" sldId="257"/>
-            <ac:picMk id="1035" creationId="{3C8C20BC-3C93-904D-6E19-1C2BDAD01BD1}"/>
-          </ac:picMkLst>
-        </pc:picChg>
-        <pc:picChg chg="del">
-          <ac:chgData name="Read, Zoe" userId="b08cd0fd-26d2-470b-8ec0-c6e6cb2a79bd" providerId="ADAL" clId="{5AEB2719-95A5-4ED2-9E0E-ED462BB10526}" dt="2026-03-06T17:16:44.799" v="525" actId="478"/>
-          <ac:picMkLst>
-            <pc:docMk/>
-            <pc:sldMk cId="2005456116" sldId="257"/>
-            <ac:picMk id="1045" creationId="{7DBC5537-F554-2AAC-970B-62CE3E978E97}"/>
+            <ac:picMk id="14" creationId="{D874F7CA-9ADB-8489-D018-7E0521CCE737}"/>
           </ac:picMkLst>
         </pc:picChg>
         <pc:cxnChg chg="mod">
-          <ac:chgData name="Read, Zoe" userId="b08cd0fd-26d2-470b-8ec0-c6e6cb2a79bd" providerId="ADAL" clId="{5AEB2719-95A5-4ED2-9E0E-ED462BB10526}" dt="2026-03-06T17:16:17.257" v="524" actId="1076"/>
+          <ac:chgData name="Read, Zoe" userId="b08cd0fd-26d2-470b-8ec0-c6e6cb2a79bd" providerId="ADAL" clId="{5AEB2719-95A5-4ED2-9E0E-ED462BB10526}" dt="2026-03-09T12:04:41.371" v="863" actId="1076"/>
           <ac:cxnSpMkLst>
             <pc:docMk/>
             <pc:sldMk cId="2005456116" sldId="257"/>
-            <ac:cxnSpMk id="20" creationId="{37958F97-D0C9-F209-A06D-4E5198F4B42E}"/>
+            <ac:cxnSpMk id="1031" creationId="{00BF45BC-03E3-27BE-C768-387C6B2C806C}"/>
           </ac:cxnSpMkLst>
         </pc:cxnChg>
         <pc:cxnChg chg="mod">
-          <ac:chgData name="Read, Zoe" userId="b08cd0fd-26d2-470b-8ec0-c6e6cb2a79bd" providerId="ADAL" clId="{5AEB2719-95A5-4ED2-9E0E-ED462BB10526}" dt="2026-03-06T17:16:17.257" v="524" actId="1076"/>
-          <ac:cxnSpMkLst>
-            <pc:docMk/>
-            <pc:sldMk cId="2005456116" sldId="257"/>
-            <ac:cxnSpMk id="21" creationId="{121263AE-A054-FFCF-E282-6730ADF6B6C0}"/>
-          </ac:cxnSpMkLst>
-        </pc:cxnChg>
-        <pc:cxnChg chg="mod">
-          <ac:chgData name="Read, Zoe" userId="b08cd0fd-26d2-470b-8ec0-c6e6cb2a79bd" providerId="ADAL" clId="{5AEB2719-95A5-4ED2-9E0E-ED462BB10526}" dt="2026-03-06T17:16:17.257" v="524" actId="1076"/>
-          <ac:cxnSpMkLst>
-            <pc:docMk/>
-            <pc:sldMk cId="2005456116" sldId="257"/>
-            <ac:cxnSpMk id="25" creationId="{5C9573CC-C13C-CF99-4ABF-F2CB540DE88F}"/>
-          </ac:cxnSpMkLst>
-        </pc:cxnChg>
-        <pc:cxnChg chg="mod">
-          <ac:chgData name="Read, Zoe" userId="b08cd0fd-26d2-470b-8ec0-c6e6cb2a79bd" providerId="ADAL" clId="{5AEB2719-95A5-4ED2-9E0E-ED462BB10526}" dt="2026-03-06T17:12:27.553" v="514" actId="1076"/>
+          <ac:chgData name="Read, Zoe" userId="b08cd0fd-26d2-470b-8ec0-c6e6cb2a79bd" providerId="ADAL" clId="{5AEB2719-95A5-4ED2-9E0E-ED462BB10526}" dt="2026-03-09T12:05:28.706" v="874" actId="1076"/>
           <ac:cxnSpMkLst>
             <pc:docMk/>
             <pc:sldMk cId="2005456116" sldId="257"/>
@@ -340,7 +252,7 @@
           </ac:cxnSpMkLst>
         </pc:cxnChg>
         <pc:cxnChg chg="mod">
-          <ac:chgData name="Read, Zoe" userId="b08cd0fd-26d2-470b-8ec0-c6e6cb2a79bd" providerId="ADAL" clId="{5AEB2719-95A5-4ED2-9E0E-ED462BB10526}" dt="2026-03-06T17:23:25.936" v="835" actId="1076"/>
+          <ac:chgData name="Read, Zoe" userId="b08cd0fd-26d2-470b-8ec0-c6e6cb2a79bd" providerId="ADAL" clId="{5AEB2719-95A5-4ED2-9E0E-ED462BB10526}" dt="2026-03-10T12:42:24.825" v="916" actId="1076"/>
           <ac:cxnSpMkLst>
             <pc:docMk/>
             <pc:sldMk cId="2005456116" sldId="257"/>
@@ -474,7 +386,7 @@
           <a:p>
             <a:fld id="{0407BD97-90D8-3541-9414-B17D17D02539}" type="datetimeFigureOut">
               <a:rPr lang="en-US" smtClean="0"/>
-              <a:t>3/6/2026</a:t>
+              <a:t>3/9/2026</a:t>
             </a:fld>
             <a:endParaRPr lang="en-US"/>
           </a:p>
@@ -2162,8 +2074,8 @@
         </p:nvSpPr>
         <p:spPr>
           <a:xfrm>
-            <a:off x="1524002" y="6548392"/>
-            <a:ext cx="13411198" cy="3525087"/>
+            <a:off x="1357241" y="5723399"/>
+            <a:ext cx="13411198" cy="1843768"/>
           </a:xfrm>
           <a:ln>
             <a:noFill/>
@@ -2191,32 +2103,6 @@
             <a:r>
               <a:rPr lang="en-US" dirty="0"/>
               <a:t>Visual hook of taking samples, COMPASS Project, Sites, and Zones – conceptual diagram or overhead photo of sites </a:t>
-            </a:r>
-          </a:p>
-          <a:p>
-            <a:endParaRPr lang="en-US" b="1" dirty="0">
-              <a:solidFill>
-                <a:srgbClr val="75BFE2"/>
-              </a:solidFill>
-            </a:endParaRPr>
-          </a:p>
-          <a:p>
-            <a:r>
-              <a:rPr lang="en-US" sz="3200" b="1" i="1" dirty="0">
-                <a:solidFill>
-                  <a:srgbClr val="75BFE2"/>
-                </a:solidFill>
-              </a:rPr>
-              <a:t>Research Questions: </a:t>
-            </a:r>
-          </a:p>
-          <a:p>
-            <a:pPr marL="514350" indent="-514350" fontAlgn="base">
-              <a:buAutoNum type="arabicPeriod"/>
-            </a:pPr>
-            <a:r>
-              <a:rPr lang="en-US" dirty="0"/>
-              <a:t>Does porewater sulfate vary by depth, across time and zones? </a:t>
             </a:r>
           </a:p>
         </p:txBody>
@@ -2614,7 +2500,7 @@
                 <a:latin typeface="Arial" panose="020B0604020202020204" pitchFamily="34" charset="0"/>
                 <a:cs typeface="Arial" panose="020B0604020202020204" pitchFamily="34" charset="0"/>
               </a:rPr>
-              <a:t>Sampling from 2022-2025  </a:t>
+              <a:t>Porewater sampling from 2022-2025  </a:t>
             </a:r>
           </a:p>
           <a:p>
@@ -2627,7 +2513,7 @@
                 <a:latin typeface="Arial" panose="020B0604020202020204" pitchFamily="34" charset="0"/>
                 <a:cs typeface="Arial" panose="020B0604020202020204" pitchFamily="34" charset="0"/>
               </a:rPr>
-              <a:t>DIC, DOC, Total Alkalinity, CDOM, H</a:t>
+              <a:t>Analyzed for DIC, DOC, Total Alkalinity, CDOM, H</a:t>
             </a:r>
             <a:r>
               <a:rPr lang="en-US" sz="2800" baseline="-25000" dirty="0">
@@ -2698,7 +2584,7 @@
         </p:nvCxnSpPr>
         <p:spPr>
           <a:xfrm>
-            <a:off x="667369" y="6067996"/>
+            <a:off x="685800" y="5577681"/>
             <a:ext cx="33375600" cy="0"/>
           </a:xfrm>
           <a:prstGeom prst="line">
@@ -2741,7 +2627,7 @@
         </p:nvCxnSpPr>
         <p:spPr>
           <a:xfrm>
-            <a:off x="1357241" y="10530681"/>
+            <a:off x="1357241" y="10759281"/>
             <a:ext cx="15862150" cy="0"/>
           </a:xfrm>
           <a:prstGeom prst="line">
@@ -2825,7 +2711,7 @@
         </p:nvCxnSpPr>
         <p:spPr>
           <a:xfrm>
-            <a:off x="1357241" y="19827081"/>
+            <a:off x="1357241" y="20094696"/>
             <a:ext cx="15862150" cy="0"/>
           </a:xfrm>
           <a:prstGeom prst="line">
@@ -3062,8 +2948,8 @@
         </p:nvSpPr>
         <p:spPr>
           <a:xfrm>
-            <a:off x="1649051" y="20094696"/>
-            <a:ext cx="8077199" cy="2328963"/>
+            <a:off x="1591901" y="20223361"/>
+            <a:ext cx="12524149" cy="2328963"/>
           </a:xfrm>
           <a:prstGeom prst="rect">
             <a:avLst/>
@@ -3245,7 +3131,7 @@
                 <a:latin typeface="Arial" panose="020B0604020202020204" pitchFamily="34" charset="0"/>
                 <a:cs typeface="Arial" panose="020B0604020202020204" pitchFamily="34" charset="0"/>
               </a:rPr>
-              <a:t>No significant variation of porewater analytes by depth</a:t>
+              <a:t>Porewater analytes vary more by Zone than by Depth</a:t>
             </a:r>
             <a:endParaRPr lang="en-US" sz="2800" dirty="0"/>
           </a:p>
@@ -3253,10 +3139,10 @@
       </p:sp>
       <p:pic>
         <p:nvPicPr>
-          <p:cNvPr id="10" name="Picture 9">
+          <p:cNvPr id="13" name="Picture 12" descr="A graph of different sizes and colors&#10;&#10;AI-generated content may be incorrect.">
             <a:extLst>
               <a:ext uri="{FF2B5EF4-FFF2-40B4-BE49-F238E27FC236}">
-                <a16:creationId xmlns:a16="http://schemas.microsoft.com/office/drawing/2014/main" id="{0A86C89A-5889-65B9-1137-F480341B9783}"/>
+                <a16:creationId xmlns:a16="http://schemas.microsoft.com/office/drawing/2014/main" id="{6D65798C-DAB9-914B-7ECA-E6D17BBC9E45}"/>
               </a:ext>
             </a:extLst>
           </p:cNvPr>
@@ -3266,27 +3152,220 @@
           <p:nvPr/>
         </p:nvPicPr>
         <p:blipFill>
-          <a:blip r:embed="rId4"/>
+          <a:blip r:embed="rId4">
+            <a:extLst>
+              <a:ext uri="{28A0092B-C50C-407E-A947-70E740481C1C}">
+                <a14:useLocalDpi xmlns:a14="http://schemas.microsoft.com/office/drawing/2010/main" val="0"/>
+              </a:ext>
+            </a:extLst>
+          </a:blip>
           <a:stretch>
             <a:fillRect/>
           </a:stretch>
         </p:blipFill>
         <p:spPr>
           <a:xfrm>
-            <a:off x="550372" y="14292339"/>
-            <a:ext cx="17087967" cy="5403712"/>
+            <a:off x="550372" y="22437884"/>
+            <a:ext cx="18288036" cy="9144018"/>
           </a:xfrm>
           <a:prstGeom prst="rect">
             <a:avLst/>
           </a:prstGeom>
         </p:spPr>
       </p:pic>
+      <p:sp>
+        <p:nvSpPr>
+          <p:cNvPr id="5" name="TextBox 4">
+            <a:extLst>
+              <a:ext uri="{FF2B5EF4-FFF2-40B4-BE49-F238E27FC236}">
+                <a16:creationId xmlns:a16="http://schemas.microsoft.com/office/drawing/2014/main" id="{611D73CC-38EE-87A4-659B-7AFB71426A3B}"/>
+              </a:ext>
+            </a:extLst>
+          </p:cNvPr>
+          <p:cNvSpPr txBox="1"/>
+          <p:nvPr/>
+        </p:nvSpPr>
+        <p:spPr>
+          <a:xfrm>
+            <a:off x="562192" y="7541832"/>
+            <a:ext cx="15862149" cy="3000821"/>
+          </a:xfrm>
+          <a:prstGeom prst="rect">
+            <a:avLst/>
+          </a:prstGeom>
+          <a:noFill/>
+        </p:spPr>
+        <p:txBody>
+          <a:bodyPr wrap="square" rtlCol="0">
+            <a:spAutoFit/>
+          </a:bodyPr>
+          <a:lstStyle/>
+          <a:p>
+            <a:pPr algn="ctr" rtl="0">
+              <a:spcBef>
+                <a:spcPts val="1000"/>
+              </a:spcBef>
+              <a:spcAft>
+                <a:spcPts val="0"/>
+              </a:spcAft>
+            </a:pPr>
+            <a:r>
+              <a:rPr lang="en-US" sz="3600" b="1" dirty="0">
+                <a:solidFill>
+                  <a:srgbClr val="75BFE2"/>
+                </a:solidFill>
+                <a:latin typeface="Arial" panose="020B0604020202020204" pitchFamily="34" charset="0"/>
+                <a:cs typeface="Arial" panose="020B0604020202020204" pitchFamily="34" charset="0"/>
+              </a:rPr>
+              <a:t>Hypothesis: </a:t>
+            </a:r>
+            <a:r>
+              <a:rPr lang="en-US" sz="3200" b="0" i="0" u="none" strike="noStrike" dirty="0">
+                <a:solidFill>
+                  <a:srgbClr val="000000"/>
+                </a:solidFill>
+                <a:effectLst/>
+                <a:latin typeface="Arial" panose="020B0604020202020204" pitchFamily="34" charset="0"/>
+                <a:cs typeface="Arial" panose="020B0604020202020204" pitchFamily="34" charset="0"/>
+              </a:rPr>
+              <a:t>There is a hierarchical structure to </a:t>
+            </a:r>
+            <a:r>
+              <a:rPr lang="en-US" sz="3200" b="0" i="0" u="sng" dirty="0">
+                <a:solidFill>
+                  <a:srgbClr val="000000"/>
+                </a:solidFill>
+                <a:effectLst/>
+                <a:latin typeface="Arial" panose="020B0604020202020204" pitchFamily="34" charset="0"/>
+                <a:cs typeface="Arial" panose="020B0604020202020204" pitchFamily="34" charset="0"/>
+              </a:rPr>
+              <a:t>spatial </a:t>
+            </a:r>
+            <a:r>
+              <a:rPr lang="en-US" sz="3200" b="0" i="0" u="none" strike="noStrike" dirty="0">
+                <a:solidFill>
+                  <a:srgbClr val="000000"/>
+                </a:solidFill>
+                <a:effectLst/>
+                <a:latin typeface="Arial" panose="020B0604020202020204" pitchFamily="34" charset="0"/>
+                <a:cs typeface="Arial" panose="020B0604020202020204" pitchFamily="34" charset="0"/>
+              </a:rPr>
+              <a:t>variation in ecosystem structure and function at the coastal TAI that is set by:</a:t>
+            </a:r>
+            <a:endParaRPr lang="en-US" sz="3200" b="0" dirty="0">
+              <a:effectLst/>
+              <a:latin typeface="Arial" panose="020B0604020202020204" pitchFamily="34" charset="0"/>
+              <a:cs typeface="Arial" panose="020B0604020202020204" pitchFamily="34" charset="0"/>
+            </a:endParaRPr>
+          </a:p>
+          <a:p>
+            <a:pPr algn="ctr" rtl="0">
+              <a:spcBef>
+                <a:spcPts val="1000"/>
+              </a:spcBef>
+              <a:spcAft>
+                <a:spcPts val="0"/>
+              </a:spcAft>
+            </a:pPr>
+            <a:r>
+              <a:rPr lang="en-US" sz="3200" b="0" i="0" u="none" strike="noStrike" dirty="0">
+                <a:solidFill>
+                  <a:srgbClr val="000000"/>
+                </a:solidFill>
+                <a:effectLst/>
+                <a:latin typeface="Arial" panose="020B0604020202020204" pitchFamily="34" charset="0"/>
+                <a:cs typeface="Arial" panose="020B0604020202020204" pitchFamily="34" charset="0"/>
+              </a:rPr>
+              <a:t>1) the </a:t>
+            </a:r>
+            <a:r>
+              <a:rPr lang="en-US" sz="3200" b="1" i="0" u="none" strike="noStrike" dirty="0">
+                <a:solidFill>
+                  <a:srgbClr val="000000"/>
+                </a:solidFill>
+                <a:effectLst/>
+                <a:latin typeface="Arial" panose="020B0604020202020204" pitchFamily="34" charset="0"/>
+                <a:cs typeface="Arial" panose="020B0604020202020204" pitchFamily="34" charset="0"/>
+              </a:rPr>
+              <a:t>depth and duration of soil saturation </a:t>
+            </a:r>
+            <a:endParaRPr lang="en-US" sz="3200" b="0" dirty="0">
+              <a:effectLst/>
+              <a:latin typeface="Arial" panose="020B0604020202020204" pitchFamily="34" charset="0"/>
+              <a:cs typeface="Arial" panose="020B0604020202020204" pitchFamily="34" charset="0"/>
+            </a:endParaRPr>
+          </a:p>
+          <a:p>
+            <a:pPr algn="ctr" rtl="0">
+              <a:spcBef>
+                <a:spcPts val="1000"/>
+              </a:spcBef>
+              <a:spcAft>
+                <a:spcPts val="0"/>
+              </a:spcAft>
+            </a:pPr>
+            <a:r>
+              <a:rPr lang="en-US" sz="3200" b="0" i="0" u="none" strike="noStrike" dirty="0">
+                <a:solidFill>
+                  <a:srgbClr val="000000"/>
+                </a:solidFill>
+                <a:effectLst/>
+                <a:latin typeface="Arial" panose="020B0604020202020204" pitchFamily="34" charset="0"/>
+                <a:cs typeface="Arial" panose="020B0604020202020204" pitchFamily="34" charset="0"/>
+              </a:rPr>
+              <a:t>2) the abundance of </a:t>
+            </a:r>
+            <a:r>
+              <a:rPr lang="en-US" sz="3200" b="1" i="0" u="none" strike="noStrike" dirty="0">
+                <a:solidFill>
+                  <a:srgbClr val="000000"/>
+                </a:solidFill>
+                <a:effectLst/>
+                <a:latin typeface="Arial" panose="020B0604020202020204" pitchFamily="34" charset="0"/>
+                <a:cs typeface="Arial" panose="020B0604020202020204" pitchFamily="34" charset="0"/>
+              </a:rPr>
+              <a:t>redox-sensitive elements</a:t>
+            </a:r>
+          </a:p>
+          <a:p>
+            <a:pPr algn="ctr" rtl="0">
+              <a:spcBef>
+                <a:spcPts val="1000"/>
+              </a:spcBef>
+              <a:spcAft>
+                <a:spcPts val="0"/>
+              </a:spcAft>
+            </a:pPr>
+            <a:r>
+              <a:rPr lang="en-US" sz="3200" b="0" dirty="0">
+                <a:effectLst/>
+                <a:latin typeface="Arial" panose="020B0604020202020204" pitchFamily="34" charset="0"/>
+                <a:cs typeface="Arial" panose="020B0604020202020204" pitchFamily="34" charset="0"/>
+              </a:rPr>
+              <a:t>3) their</a:t>
+            </a:r>
+            <a:r>
+              <a:rPr lang="en-US" sz="3200" b="1" dirty="0">
+                <a:effectLst/>
+                <a:latin typeface="Arial" panose="020B0604020202020204" pitchFamily="34" charset="0"/>
+                <a:cs typeface="Arial" panose="020B0604020202020204" pitchFamily="34" charset="0"/>
+              </a:rPr>
+              <a:t> interactions with plant traits</a:t>
+            </a:r>
+            <a:endParaRPr lang="en-US" b="0" dirty="0">
+              <a:effectLst/>
+              <a:latin typeface="Arial" panose="020B0604020202020204" pitchFamily="34" charset="0"/>
+              <a:cs typeface="Arial" panose="020B0604020202020204" pitchFamily="34" charset="0"/>
+            </a:endParaRPr>
+          </a:p>
+        </p:txBody>
+      </p:sp>
       <p:pic>
         <p:nvPicPr>
-          <p:cNvPr id="13" name="Picture 12" descr="A graph of different sizes and colors&#10;&#10;AI-generated content may be incorrect.">
+          <p:cNvPr id="14" name="Picture 13" descr="A graph of different colored lines&#10;&#10;AI-generated content may be incorrect.">
             <a:extLst>
               <a:ext uri="{FF2B5EF4-FFF2-40B4-BE49-F238E27FC236}">
-                <a16:creationId xmlns:a16="http://schemas.microsoft.com/office/drawing/2014/main" id="{6D65798C-DAB9-914B-7ECA-E6D17BBC9E45}"/>
+                <a16:creationId xmlns:a16="http://schemas.microsoft.com/office/drawing/2014/main" id="{D874F7CA-9ADB-8489-D018-7E0521CCE737}"/>
               </a:ext>
             </a:extLst>
           </p:cNvPr>
@@ -3309,8 +3388,8 @@
         </p:blipFill>
         <p:spPr>
           <a:xfrm>
-            <a:off x="550372" y="22437884"/>
-            <a:ext cx="18288036" cy="9144018"/>
+            <a:off x="525316" y="14245584"/>
+            <a:ext cx="17526000" cy="5842000"/>
           </a:xfrm>
           <a:prstGeom prst="rect">
             <a:avLst/>

</xml_diff>